<commit_message>
chore: update PPTX deck with 25% O&M opportunity margin
</commit_message>
<xml_diff>
--- a/FY2027_進金生南區暨維運商業計畫報告_董總決策版.pptx
+++ b/FY2027_進金生南區暨維運商業計畫報告_董總決策版.pptx
@@ -22550,7 +22550,7 @@
                         </a:defRPr>
                       </a:pPr>
                       <a:r>
-                        <a:t>15.0%</a:t>
+                        <a:t>25.0%</a:t>
                       </a:r>
                     </a:p>
                   </a:txBody>
@@ -22694,7 +22694,7 @@
                         </a:defRPr>
                       </a:pPr>
                       <a:r>
-                        <a:t>14,927</a:t>
+                        <a:t>24,876</a:t>
                       </a:r>
                     </a:p>
                   </a:txBody>
@@ -22792,7 +22792,7 @@
                         </a:defRPr>
                       </a:pPr>
                       <a:r>
-                        <a:t>24.9%</a:t>
+                        <a:t>25.0%</a:t>
                       </a:r>
                     </a:p>
                   </a:txBody>
@@ -22936,7 +22936,7 @@
                         </a:defRPr>
                       </a:pPr>
                       <a:r>
-                        <a:t>5,971</a:t>
+                        <a:t>6,000</a:t>
                       </a:r>
                     </a:p>
                   </a:txBody>
@@ -23034,7 +23034,7 @@
                         </a:defRPr>
                       </a:pPr>
                       <a:r>
-                        <a:t>15.0%</a:t>
+                        <a:t>25.0%</a:t>
                       </a:r>
                     </a:p>
                   </a:txBody>
@@ -23178,7 +23178,7 @@
                         </a:defRPr>
                       </a:pPr>
                       <a:r>
-                        <a:t>5,334</a:t>
+                        <a:t>8,888</a:t>
                       </a:r>
                     </a:p>
                   </a:txBody>
@@ -23276,7 +23276,7 @@
                         </a:defRPr>
                       </a:pPr>
                       <a:r>
-                        <a:t>15.0%</a:t>
+                        <a:t>25.0%</a:t>
                       </a:r>
                     </a:p>
                   </a:txBody>
@@ -23420,7 +23420,7 @@
                         </a:defRPr>
                       </a:pPr>
                       <a:r>
-                        <a:t>53,438</a:t>
+                        <a:t>89,063</a:t>
                       </a:r>
                     </a:p>
                   </a:txBody>
@@ -23518,7 +23518,7 @@
                         </a:defRPr>
                       </a:pPr>
                       <a:r>
-                        <a:t>15.0%</a:t>
+                        <a:t>25.0%</a:t>
                       </a:r>
                     </a:p>
                   </a:txBody>
@@ -23662,7 +23662,7 @@
                         </a:defRPr>
                       </a:pPr>
                       <a:r>
-                        <a:t>393,750</a:t>
+                        <a:t>656,250</a:t>
                       </a:r>
                     </a:p>
                   </a:txBody>
@@ -23760,7 +23760,7 @@
                         </a:defRPr>
                       </a:pPr>
                       <a:r>
-                        <a:t>15.0%</a:t>
+                        <a:t>25.0%</a:t>
                       </a:r>
                     </a:p>
                   </a:txBody>
@@ -23904,7 +23904,7 @@
                         </a:defRPr>
                       </a:pPr>
                       <a:r>
-                        <a:t>23,639</a:t>
+                        <a:t>39,396</a:t>
                       </a:r>
                     </a:p>
                   </a:txBody>
@@ -24002,7 +24002,7 @@
                         </a:defRPr>
                       </a:pPr>
                       <a:r>
-                        <a:t>15.0%</a:t>
+                        <a:t>25.0%</a:t>
                       </a:r>
                     </a:p>
                   </a:txBody>
@@ -24146,7 +24146,7 @@
                         </a:defRPr>
                       </a:pPr>
                       <a:r>
-                        <a:t>18,004</a:t>
+                        <a:t>30,012</a:t>
                       </a:r>
                     </a:p>
                   </a:txBody>
@@ -24244,7 +24244,7 @@
                         </a:defRPr>
                       </a:pPr>
                       <a:r>
-                        <a:t>15.0%</a:t>
+                        <a:t>25.0%</a:t>
                       </a:r>
                     </a:p>
                   </a:txBody>
@@ -24388,7 +24388,7 @@
                         </a:defRPr>
                       </a:pPr>
                       <a:r>
-                        <a:t>2,083,725</a:t>
+                        <a:t>3,472,878</a:t>
                       </a:r>
                     </a:p>
                   </a:txBody>
@@ -24486,7 +24486,7 @@
                         </a:defRPr>
                       </a:pPr>
                       <a:r>
-                        <a:t>15.0%</a:t>
+                        <a:t>25.0%</a:t>
                       </a:r>
                     </a:p>
                   </a:txBody>
@@ -24630,7 +24630,7 @@
                         </a:defRPr>
                       </a:pPr>
                       <a:r>
-                        <a:t>6,629</a:t>
+                        <a:t>11,052</a:t>
                       </a:r>
                     </a:p>
                   </a:txBody>
@@ -24728,7 +24728,7 @@
                         </a:defRPr>
                       </a:pPr>
                       <a:r>
-                        <a:t>15.0%</a:t>
+                        <a:t>25.0%</a:t>
                       </a:r>
                     </a:p>
                   </a:txBody>
@@ -24872,7 +24872,7 @@
                         </a:defRPr>
                       </a:pPr>
                       <a:r>
-                        <a:t>1,500,000</a:t>
+                        <a:t>2,500,000</a:t>
                       </a:r>
                     </a:p>
                   </a:txBody>
@@ -24970,7 +24970,7 @@
                         </a:defRPr>
                       </a:pPr>
                       <a:r>
-                        <a:t>15.0%</a:t>
+                        <a:t>25.0%</a:t>
                       </a:r>
                     </a:p>
                   </a:txBody>
@@ -25114,7 +25114,7 @@
                         </a:defRPr>
                       </a:pPr>
                       <a:r>
-                        <a:t>1,125,000</a:t>
+                        <a:t>1,875,000</a:t>
                       </a:r>
                     </a:p>
                   </a:txBody>
@@ -25212,7 +25212,7 @@
                         </a:defRPr>
                       </a:pPr>
                       <a:r>
-                        <a:t>15.0%</a:t>
+                        <a:t>25.0%</a:t>
                       </a:r>
                     </a:p>
                   </a:txBody>
@@ -25356,7 +25356,7 @@
                         </a:defRPr>
                       </a:pPr>
                       <a:r>
-                        <a:t>1,500,000</a:t>
+                        <a:t>2,499,997</a:t>
                       </a:r>
                     </a:p>
                   </a:txBody>
@@ -25454,7 +25454,7 @@
                         </a:defRPr>
                       </a:pPr>
                       <a:r>
-                        <a:t>15.0%</a:t>
+                        <a:t>25.0%</a:t>
                       </a:r>
                     </a:p>
                   </a:txBody>
@@ -25598,7 +25598,7 @@
                         </a:defRPr>
                       </a:pPr>
                       <a:r>
-                        <a:t>1,500,000</a:t>
+                        <a:t>2,500,001</a:t>
                       </a:r>
                     </a:p>
                   </a:txBody>
@@ -25696,7 +25696,7 @@
                         </a:defRPr>
                       </a:pPr>
                       <a:r>
-                        <a:t>15.0%</a:t>
+                        <a:t>25.0%</a:t>
                       </a:r>
                     </a:p>
                   </a:txBody>
@@ -25840,7 +25840,7 @@
                         </a:defRPr>
                       </a:pPr>
                       <a:r>
-                        <a:t>136,764</a:t>
+                        <a:t>227,940</a:t>
                       </a:r>
                     </a:p>
                   </a:txBody>
@@ -25938,7 +25938,7 @@
                         </a:defRPr>
                       </a:pPr>
                       <a:r>
-                        <a:t>15.0%</a:t>
+                        <a:t>25.0%</a:t>
                       </a:r>
                     </a:p>
                   </a:txBody>
@@ -26082,7 +26082,7 @@
                         </a:defRPr>
                       </a:pPr>
                       <a:r>
-                        <a:t>13,496</a:t>
+                        <a:t>22,500</a:t>
                       </a:r>
                     </a:p>
                   </a:txBody>
@@ -26180,7 +26180,7 @@
                         </a:defRPr>
                       </a:pPr>
                       <a:r>
-                        <a:t>15.0%</a:t>
+                        <a:t>25.0%</a:t>
                       </a:r>
                     </a:p>
                   </a:txBody>
@@ -26324,7 +26324,7 @@
                         </a:defRPr>
                       </a:pPr>
                       <a:r>
-                        <a:t>32,375</a:t>
+                        <a:t>53,964</a:t>
                       </a:r>
                     </a:p>
                   </a:txBody>
@@ -26422,7 +26422,7 @@
                         </a:defRPr>
                       </a:pPr>
                       <a:r>
-                        <a:t>15.0%</a:t>
+                        <a:t>25.0%</a:t>
                       </a:r>
                     </a:p>
                   </a:txBody>
@@ -26566,7 +26566,7 @@
                         </a:defRPr>
                       </a:pPr>
                       <a:r>
-                        <a:t>3,575</a:t>
+                        <a:t>5,964</a:t>
                       </a:r>
                     </a:p>
                   </a:txBody>
@@ -26664,7 +26664,7 @@
                         </a:defRPr>
                       </a:pPr>
                       <a:r>
-                        <a:t>15.0%</a:t>
+                        <a:t>25.0%</a:t>
                       </a:r>
                     </a:p>
                   </a:txBody>
@@ -26808,7 +26808,7 @@
                         </a:defRPr>
                       </a:pPr>
                       <a:r>
-                        <a:t>35,984</a:t>
+                        <a:t>59,976</a:t>
                       </a:r>
                     </a:p>
                   </a:txBody>
@@ -26906,7 +26906,7 @@
                         </a:defRPr>
                       </a:pPr>
                       <a:r>
-                        <a:t>15.0%</a:t>
+                        <a:t>25.0%</a:t>
                       </a:r>
                     </a:p>
                   </a:txBody>
@@ -27050,7 +27050,7 @@
                         </a:defRPr>
                       </a:pPr>
                       <a:r>
-                        <a:t>375,000</a:t>
+                        <a:t>625,000</a:t>
                       </a:r>
                     </a:p>
                   </a:txBody>
@@ -27148,7 +27148,7 @@
                         </a:defRPr>
                       </a:pPr>
                       <a:r>
-                        <a:t>15.0%</a:t>
+                        <a:t>25.0%</a:t>
                       </a:r>
                     </a:p>
                   </a:txBody>
@@ -27292,7 +27292,7 @@
                         </a:defRPr>
                       </a:pPr>
                       <a:r>
-                        <a:t>148,500</a:t>
+                        <a:t>247,500</a:t>
                       </a:r>
                     </a:p>
                   </a:txBody>
@@ -27390,7 +27390,7 @@
                         </a:defRPr>
                       </a:pPr>
                       <a:r>
-                        <a:t>15.0%</a:t>
+                        <a:t>25.0%</a:t>
                       </a:r>
                     </a:p>
                   </a:txBody>
@@ -27534,7 +27534,7 @@
                         </a:defRPr>
                       </a:pPr>
                       <a:r>
-                        <a:t>8,976,124</a:t>
+                        <a:t>14,956,257</a:t>
                       </a:r>
                     </a:p>
                   </a:txBody>
@@ -28340,7 +28340,7 @@
                         </a:defRPr>
                       </a:pPr>
                       <a:r>
-                        <a:t>毛利 23,365,076 (23.15%)</a:t>
+                        <a:t>毛利 29,345,209 (29.07%)</a:t>
                       </a:r>
                     </a:p>
                   </a:txBody>
@@ -37570,7 +37570,7 @@
               </a:defRPr>
             </a:pPr>
             <a:r>
-              <a:t>維運事業 2027 預算突破 1.01 億元（毛利 2,337 萬 / 毛利率 23.15%），128 筆長約貢獻 61.6% 高毛利鐵票</a:t>
+              <a:t>維運事業 2027 預算突破 1.01 億元（毛利 2,935 萬 / 毛利率 29.07%），長約與新商機雙引擎各貢獻約 50% 毛利</a:t>
             </a:r>
           </a:p>
           <a:p>
@@ -37583,7 +37583,7 @@
               </a:defRPr>
             </a:pPr>
             <a:r>
-              <a:t>JDE 已簽維運合約 4,111 萬（毛利率 35.0%）穩健護盤；前十大合約占 50.8%，涵蓋 PROJECT AMEI、永堯、中租、群創</a:t>
+              <a:t>JDE 已簽長約 4,111 萬（毛利率 35.0% / 毛利 1,439 萬）＋ 新增維運與修繕機會 5,982 萬（毛利率 25.0% / 毛利 1,496 萬）</a:t>
             </a:r>
           </a:p>
         </p:txBody>
@@ -37980,7 +37980,7 @@
                         </a:defRPr>
                       </a:pPr>
                       <a:r>
-                        <a:t>61.6%</a:t>
+                        <a:t>49.0%</a:t>
                       </a:r>
                     </a:p>
                   </a:txBody>
@@ -38102,7 +38102,7 @@
                         </a:defRPr>
                       </a:pPr>
                       <a:r>
-                        <a:t>8,976,124</a:t>
+                        <a:t>14,956,257</a:t>
                       </a:r>
                     </a:p>
                   </a:txBody>
@@ -38126,7 +38126,7 @@
                         </a:defRPr>
                       </a:pPr>
                       <a:r>
-                        <a:t>15.0%</a:t>
+                        <a:t>25.0%</a:t>
                       </a:r>
                     </a:p>
                   </a:txBody>
@@ -38150,7 +38150,7 @@
                         </a:defRPr>
                       </a:pPr>
                       <a:r>
-                        <a:t>38.4%</a:t>
+                        <a:t>51.0%</a:t>
                       </a:r>
                     </a:p>
                   </a:txBody>
@@ -38272,7 +38272,7 @@
                         </a:defRPr>
                       </a:pPr>
                       <a:r>
-                        <a:t>23,365,076</a:t>
+                        <a:t>29,345,209</a:t>
                       </a:r>
                     </a:p>
                   </a:txBody>
@@ -38296,7 +38296,7 @@
                         </a:defRPr>
                       </a:pPr>
                       <a:r>
-                        <a:t>23.15%</a:t>
+                        <a:t>29.07%</a:t>
                       </a:r>
                     </a:p>
                   </a:txBody>
@@ -38545,7 +38545,7 @@
                         </a:defRPr>
                       </a:pPr>
                       <a:r>
-                        <a:t>5,236,965</a:t>
+                        <a:t>6,266,237</a:t>
                       </a:r>
                     </a:p>
                   </a:txBody>
@@ -38569,7 +38569,7 @@
                         </a:defRPr>
                       </a:pPr>
                       <a:r>
-                        <a:t>25.12%</a:t>
+                        <a:t>30.06%</a:t>
                       </a:r>
                     </a:p>
                   </a:txBody>
@@ -38667,7 +38667,7 @@
                         </a:defRPr>
                       </a:pPr>
                       <a:r>
-                        <a:t>6,638,476</a:t>
+                        <a:t>8,612,762</a:t>
                       </a:r>
                     </a:p>
                   </a:txBody>
@@ -38691,7 +38691,7 @@
                         </a:defRPr>
                       </a:pPr>
                       <a:r>
-                        <a:t>21.95%</a:t>
+                        <a:t>28.47%</a:t>
                       </a:r>
                     </a:p>
                   </a:txBody>
@@ -38789,7 +38789,7 @@
                         </a:defRPr>
                       </a:pPr>
                       <a:r>
-                        <a:t>6,238,240</a:t>
+                        <a:t>8,032,811</a:t>
                       </a:r>
                     </a:p>
                   </a:txBody>
@@ -38813,7 +38813,7 @@
                         </a:defRPr>
                       </a:pPr>
                       <a:r>
-                        <a:t>22.22%</a:t>
+                        <a:t>28.61%</a:t>
                       </a:r>
                     </a:p>
                   </a:txBody>
@@ -38911,7 +38911,7 @@
                         </a:defRPr>
                       </a:pPr>
                       <a:r>
-                        <a:t>5,251,395</a:t>
+                        <a:t>6,433,399</a:t>
                       </a:r>
                     </a:p>
                   </a:txBody>
@@ -38935,7 +38935,7 @@
                         </a:defRPr>
                       </a:pPr>
                       <a:r>
-                        <a:t>24.13%</a:t>
+                        <a:t>29.57%</a:t>
                       </a:r>
                     </a:p>
                   </a:txBody>

</xml_diff>

<commit_message>
feat: shift O&M repair projects to Q3/Q4 typhoon season and update quarterly/monthly figures
</commit_message>
<xml_diff>
--- a/FY2027_進金生南區暨維運商業計畫報告_董總決策版.pptx
+++ b/FY2027_進金生南區暨維運商業計畫報告_董總決策版.pptx
@@ -951,10 +951,10 @@
                   <c:v>Q2</c:v>
                 </c:pt>
                 <c:pt idx="2">
-                  <c:v>Q3</c:v>
+                  <c:v>Q3 (修繕高峰)</c:v>
                 </c:pt>
                 <c:pt idx="3">
-                  <c:v>Q4</c:v>
+                  <c:v>Q4 (修繕高峰)</c:v>
                 </c:pt>
               </c:strCache>
             </c:strRef>
@@ -1007,10 +1007,10 @@
                   <c:v>Q2</c:v>
                 </c:pt>
                 <c:pt idx="2">
-                  <c:v>Q3</c:v>
+                  <c:v>Q3 (修繕高峰)</c:v>
                 </c:pt>
                 <c:pt idx="3">
-                  <c:v>Q4</c:v>
+                  <c:v>Q4 (修繕高峰)</c:v>
                 </c:pt>
               </c:strCache>
             </c:strRef>
@@ -1022,16 +1022,16 @@
                 <c:formatCode>General</c:formatCode>
                 <c:ptCount val="4"/>
                 <c:pt idx="0">
-                  <c:v>1030</c:v>
+                  <c:v>442</c:v>
                 </c:pt>
                 <c:pt idx="1">
-                  <c:v>1975</c:v>
+                  <c:v>739</c:v>
                 </c:pt>
                 <c:pt idx="2">
-                  <c:v>1795</c:v>
+                  <c:v>2383</c:v>
                 </c:pt>
                 <c:pt idx="3">
-                  <c:v>1183</c:v>
+                  <c:v>2419</c:v>
                 </c:pt>
               </c:numCache>
             </c:numRef>
@@ -24268,7 +24268,31 @@
                         </a:defRPr>
                       </a:pPr>
                       <a:r>
-                        <a:t>4,630,500</a:t>
+                        <a:t>0</a:t>
+                      </a:r>
+                    </a:p>
+                  </a:txBody>
+                  <a:tcPr>
+                    <a:solidFill>
+                      <a:srgbClr val="142742"/>
+                    </a:solidFill>
+                  </a:tcPr>
+                </a:tc>
+                <a:tc>
+                  <a:txBody>
+                    <a:bodyPr/>
+                    <a:lstStyle/>
+                    <a:p>
+                      <a:pPr algn="r">
+                        <a:defRPr sz="750">
+                          <a:solidFill>
+                            <a:srgbClr val="F8FAFC"/>
+                          </a:solidFill>
+                          <a:latin typeface="Microsoft JhengHei"/>
+                        </a:defRPr>
+                      </a:pPr>
+                      <a:r>
+                        <a:t>0</a:t>
                       </a:r>
                     </a:p>
                   </a:txBody>
@@ -24316,31 +24340,7 @@
                         </a:defRPr>
                       </a:pPr>
                       <a:r>
-                        <a:t>2,315,250</a:t>
-                      </a:r>
-                    </a:p>
-                  </a:txBody>
-                  <a:tcPr>
-                    <a:solidFill>
-                      <a:srgbClr val="142742"/>
-                    </a:solidFill>
-                  </a:tcPr>
-                </a:tc>
-                <a:tc>
-                  <a:txBody>
-                    <a:bodyPr/>
-                    <a:lstStyle/>
-                    <a:p>
-                      <a:pPr algn="r">
-                        <a:defRPr sz="750">
-                          <a:solidFill>
-                            <a:srgbClr val="F8FAFC"/>
-                          </a:solidFill>
-                          <a:latin typeface="Microsoft JhengHei"/>
-                        </a:defRPr>
-                      </a:pPr>
-                      <a:r>
-                        <a:t>0</a:t>
+                        <a:t>6,945,750</a:t>
                       </a:r>
                     </a:p>
                   </a:txBody>
@@ -24994,7 +24994,31 @@
                         </a:defRPr>
                       </a:pPr>
                       <a:r>
-                        <a:t>1,250,000</a:t>
+                        <a:t>0</a:t>
+                      </a:r>
+                    </a:p>
+                  </a:txBody>
+                  <a:tcPr>
+                    <a:solidFill>
+                      <a:srgbClr val="0C192C"/>
+                    </a:solidFill>
+                  </a:tcPr>
+                </a:tc>
+                <a:tc>
+                  <a:txBody>
+                    <a:bodyPr/>
+                    <a:lstStyle/>
+                    <a:p>
+                      <a:pPr algn="r">
+                        <a:defRPr sz="750">
+                          <a:solidFill>
+                            <a:srgbClr val="F8FAFC"/>
+                          </a:solidFill>
+                          <a:latin typeface="Microsoft JhengHei"/>
+                        </a:defRPr>
+                      </a:pPr>
+                      <a:r>
+                        <a:t>0</a:t>
                       </a:r>
                     </a:p>
                   </a:txBody>
@@ -25042,31 +25066,7 @@
                         </a:defRPr>
                       </a:pPr>
                       <a:r>
-                        <a:t>2,500,000</a:t>
-                      </a:r>
-                    </a:p>
-                  </a:txBody>
-                  <a:tcPr>
-                    <a:solidFill>
-                      <a:srgbClr val="0C192C"/>
-                    </a:solidFill>
-                  </a:tcPr>
-                </a:tc>
-                <a:tc>
-                  <a:txBody>
-                    <a:bodyPr/>
-                    <a:lstStyle/>
-                    <a:p>
-                      <a:pPr algn="r">
-                        <a:defRPr sz="750">
-                          <a:solidFill>
-                            <a:srgbClr val="F8FAFC"/>
-                          </a:solidFill>
-                          <a:latin typeface="Microsoft JhengHei"/>
-                        </a:defRPr>
-                      </a:pPr>
-                      <a:r>
-                        <a:t>0</a:t>
+                        <a:t>3,750,000</a:t>
                       </a:r>
                     </a:p>
                   </a:txBody>
@@ -25502,7 +25502,31 @@
                         </a:defRPr>
                       </a:pPr>
                       <a:r>
-                        <a:t>1,666,665</a:t>
+                        <a:t>0</a:t>
+                      </a:r>
+                    </a:p>
+                  </a:txBody>
+                  <a:tcPr>
+                    <a:solidFill>
+                      <a:srgbClr val="0C192C"/>
+                    </a:solidFill>
+                  </a:tcPr>
+                </a:tc>
+                <a:tc>
+                  <a:txBody>
+                    <a:bodyPr/>
+                    <a:lstStyle/>
+                    <a:p>
+                      <a:pPr algn="r">
+                        <a:defRPr sz="750">
+                          <a:solidFill>
+                            <a:srgbClr val="F8FAFC"/>
+                          </a:solidFill>
+                          <a:latin typeface="Microsoft JhengHei"/>
+                        </a:defRPr>
+                      </a:pPr>
+                      <a:r>
+                        <a:t>4,999,999</a:t>
                       </a:r>
                     </a:p>
                   </a:txBody>
@@ -25527,30 +25551,6 @@
                       </a:pPr>
                       <a:r>
                         <a:t>5,000,001</a:t>
-                      </a:r>
-                    </a:p>
-                  </a:txBody>
-                  <a:tcPr>
-                    <a:solidFill>
-                      <a:srgbClr val="0C192C"/>
-                    </a:solidFill>
-                  </a:tcPr>
-                </a:tc>
-                <a:tc>
-                  <a:txBody>
-                    <a:bodyPr/>
-                    <a:lstStyle/>
-                    <a:p>
-                      <a:pPr algn="r">
-                        <a:defRPr sz="750">
-                          <a:solidFill>
-                            <a:srgbClr val="F8FAFC"/>
-                          </a:solidFill>
-                          <a:latin typeface="Microsoft JhengHei"/>
-                        </a:defRPr>
-                      </a:pPr>
-                      <a:r>
-                        <a:t>3,333,334</a:t>
                       </a:r>
                     </a:p>
                   </a:txBody>
@@ -27414,79 +27414,79 @@
                         </a:defRPr>
                       </a:pPr>
                       <a:r>
-                        <a:t>10,298,625</a:t>
-                      </a:r>
-                    </a:p>
-                  </a:txBody>
-                  <a:tcPr>
-                    <a:solidFill>
-                      <a:srgbClr val="0C192C"/>
-                    </a:solidFill>
-                  </a:tcPr>
-                </a:tc>
-                <a:tc>
-                  <a:txBody>
-                    <a:bodyPr/>
-                    <a:lstStyle/>
-                    <a:p>
-                      <a:pPr algn="r">
-                        <a:defRPr sz="750">
-                          <a:solidFill>
-                            <a:srgbClr val="F8FAFC"/>
-                          </a:solidFill>
-                          <a:latin typeface="Microsoft JhengHei"/>
-                        </a:defRPr>
-                      </a:pPr>
-                      <a:r>
-                        <a:t>19,748,769</a:t>
-                      </a:r>
-                    </a:p>
-                  </a:txBody>
-                  <a:tcPr>
-                    <a:solidFill>
-                      <a:srgbClr val="0C192C"/>
-                    </a:solidFill>
-                  </a:tcPr>
-                </a:tc>
-                <a:tc>
-                  <a:txBody>
-                    <a:bodyPr/>
-                    <a:lstStyle/>
-                    <a:p>
-                      <a:pPr algn="r">
-                        <a:defRPr sz="750">
-                          <a:solidFill>
-                            <a:srgbClr val="F8FAFC"/>
-                          </a:solidFill>
-                          <a:latin typeface="Microsoft JhengHei"/>
-                        </a:defRPr>
-                      </a:pPr>
-                      <a:r>
-                        <a:t>17,951,605</a:t>
-                      </a:r>
-                    </a:p>
-                  </a:txBody>
-                  <a:tcPr>
-                    <a:solidFill>
-                      <a:srgbClr val="0C192C"/>
-                    </a:solidFill>
-                  </a:tcPr>
-                </a:tc>
-                <a:tc>
-                  <a:txBody>
-                    <a:bodyPr/>
-                    <a:lstStyle/>
-                    <a:p>
-                      <a:pPr algn="r">
-                        <a:defRPr sz="750">
-                          <a:solidFill>
-                            <a:srgbClr val="F8FAFC"/>
-                          </a:solidFill>
-                          <a:latin typeface="Microsoft JhengHei"/>
-                        </a:defRPr>
-                      </a:pPr>
-                      <a:r>
-                        <a:t>11,825,938</a:t>
+                        <a:t>4,418,125</a:t>
+                      </a:r>
+                    </a:p>
+                  </a:txBody>
+                  <a:tcPr>
+                    <a:solidFill>
+                      <a:srgbClr val="0C192C"/>
+                    </a:solidFill>
+                  </a:tcPr>
+                </a:tc>
+                <a:tc>
+                  <a:txBody>
+                    <a:bodyPr/>
+                    <a:lstStyle/>
+                    <a:p>
+                      <a:pPr algn="r">
+                        <a:defRPr sz="750">
+                          <a:solidFill>
+                            <a:srgbClr val="F8FAFC"/>
+                          </a:solidFill>
+                          <a:latin typeface="Microsoft JhengHei"/>
+                        </a:defRPr>
+                      </a:pPr>
+                      <a:r>
+                        <a:t>7,386,354</a:t>
+                      </a:r>
+                    </a:p>
+                  </a:txBody>
+                  <a:tcPr>
+                    <a:solidFill>
+                      <a:srgbClr val="0C192C"/>
+                    </a:solidFill>
+                  </a:tcPr>
+                </a:tc>
+                <a:tc>
+                  <a:txBody>
+                    <a:bodyPr/>
+                    <a:lstStyle/>
+                    <a:p>
+                      <a:pPr algn="r">
+                        <a:defRPr sz="750">
+                          <a:solidFill>
+                            <a:srgbClr val="F8FAFC"/>
+                          </a:solidFill>
+                          <a:latin typeface="Microsoft JhengHei"/>
+                        </a:defRPr>
+                      </a:pPr>
+                      <a:r>
+                        <a:t>23,832,103</a:t>
+                      </a:r>
+                    </a:p>
+                  </a:txBody>
+                  <a:tcPr>
+                    <a:solidFill>
+                      <a:srgbClr val="0C192C"/>
+                    </a:solidFill>
+                  </a:tcPr>
+                </a:tc>
+                <a:tc>
+                  <a:txBody>
+                    <a:bodyPr/>
+                    <a:lstStyle/>
+                    <a:p>
+                      <a:pPr algn="r">
+                        <a:defRPr sz="750">
+                          <a:solidFill>
+                            <a:srgbClr val="F8FAFC"/>
+                          </a:solidFill>
+                          <a:latin typeface="Microsoft JhengHei"/>
+                        </a:defRPr>
+                      </a:pPr>
+                      <a:r>
+                        <a:t>24,188,355</a:t>
                       </a:r>
                     </a:p>
                   </a:txBody>
@@ -38521,7 +38521,7 @@
                         </a:defRPr>
                       </a:pPr>
                       <a:r>
-                        <a:t>20,845,968</a:t>
+                        <a:t>14,965,468</a:t>
                       </a:r>
                     </a:p>
                   </a:txBody>
@@ -38545,7 +38545,7 @@
                         </a:defRPr>
                       </a:pPr>
                       <a:r>
-                        <a:t>6,266,237</a:t>
+                        <a:t>4,796,111</a:t>
                       </a:r>
                     </a:p>
                   </a:txBody>
@@ -38569,7 +38569,7 @@
                         </a:defRPr>
                       </a:pPr>
                       <a:r>
-                        <a:t>30.06%</a:t>
+                        <a:t>32.05%</a:t>
                       </a:r>
                     </a:p>
                   </a:txBody>
@@ -38593,7 +38593,7 @@
                         </a:defRPr>
                       </a:pPr>
                       <a:r>
-                        <a:t>49.4% (長約護盤)</a:t>
+                        <a:t>29.5% (長約護盤)</a:t>
                       </a:r>
                     </a:p>
                   </a:txBody>
@@ -38619,7 +38619,7 @@
                         </a:defRPr>
                       </a:pPr>
                       <a:r>
-                        <a:t>Q2 第二季 (修繕高峰)</a:t>
+                        <a:t>Q2 第二季</a:t>
                       </a:r>
                     </a:p>
                   </a:txBody>
@@ -38643,7 +38643,7 @@
                         </a:defRPr>
                       </a:pPr>
                       <a:r>
-                        <a:t>30,250,370</a:t>
+                        <a:t>17,887,955</a:t>
                       </a:r>
                     </a:p>
                   </a:txBody>
@@ -38667,7 +38667,7 @@
                         </a:defRPr>
                       </a:pPr>
                       <a:r>
-                        <a:t>8,612,762</a:t>
+                        <a:t>5,522,157</a:t>
                       </a:r>
                     </a:p>
                   </a:txBody>
@@ -38691,7 +38691,7 @@
                         </a:defRPr>
                       </a:pPr>
                       <a:r>
-                        <a:t>28.47%</a:t>
+                        <a:t>30.87%</a:t>
                       </a:r>
                     </a:p>
                   </a:txBody>
@@ -38715,7 +38715,7 @@
                         </a:defRPr>
                       </a:pPr>
                       <a:r>
-                        <a:t>65.3% (旭忠/外來案)</a:t>
+                        <a:t>41.3% (外來案爬升)</a:t>
                       </a:r>
                     </a:p>
                   </a:txBody>
@@ -38741,7 +38741,7 @@
                         </a:defRPr>
                       </a:pPr>
                       <a:r>
-                        <a:t>Q3 第三季 (修繕高峰)</a:t>
+                        <a:t>Q3 第三季 (颱風修繕高峰)</a:t>
                       </a:r>
                     </a:p>
                   </a:txBody>
@@ -38765,7 +38765,7 @@
                         </a:defRPr>
                       </a:pPr>
                       <a:r>
-                        <a:t>28,079,892</a:t>
+                        <a:t>33,960,390</a:t>
                       </a:r>
                     </a:p>
                   </a:txBody>
@@ -38789,7 +38789,7 @@
                         </a:defRPr>
                       </a:pPr>
                       <a:r>
-                        <a:t>8,032,811</a:t>
+                        <a:t>9,502,936</a:t>
                       </a:r>
                     </a:p>
                   </a:txBody>
@@ -38813,7 +38813,7 @@
                         </a:defRPr>
                       </a:pPr>
                       <a:r>
-                        <a:t>28.61%</a:t>
+                        <a:t>27.98%</a:t>
                       </a:r>
                     </a:p>
                   </a:txBody>
@@ -38837,7 +38837,7 @@
                         </a:defRPr>
                       </a:pPr>
                       <a:r>
-                        <a:t>63.9% (大型修繕案)</a:t>
+                        <a:t>70.2% (災後修繕集中)</a:t>
                       </a:r>
                     </a:p>
                   </a:txBody>
@@ -38863,7 +38863,7 @@
                         </a:defRPr>
                       </a:pPr>
                       <a:r>
-                        <a:t>Q4 第四季</a:t>
+                        <a:t>Q4 第四季 (颱風修繕高峰)</a:t>
                       </a:r>
                     </a:p>
                   </a:txBody>
@@ -38887,7 +38887,7 @@
                         </a:defRPr>
                       </a:pPr>
                       <a:r>
-                        <a:t>21,759,956</a:t>
+                        <a:t>34,122,373</a:t>
                       </a:r>
                     </a:p>
                   </a:txBody>
@@ -38911,7 +38911,7 @@
                         </a:defRPr>
                       </a:pPr>
                       <a:r>
-                        <a:t>6,433,399</a:t>
+                        <a:t>9,524,005</a:t>
                       </a:r>
                     </a:p>
                   </a:txBody>
@@ -38935,7 +38935,7 @@
                         </a:defRPr>
                       </a:pPr>
                       <a:r>
-                        <a:t>29.57%</a:t>
+                        <a:t>27.91%</a:t>
                       </a:r>
                     </a:p>
                   </a:txBody>
@@ -38959,7 +38959,7 @@
                         </a:defRPr>
                       </a:pPr>
                       <a:r>
-                        <a:t>54.3% (穩定收尾)</a:t>
+                        <a:t>70.9% (災後修繕集中)</a:t>
                       </a:r>
                     </a:p>
                   </a:txBody>

</xml_diff>

<commit_message>
Adjust O&M repair engineering peak season to Q2, Q3, and Q4 (May-Dec plum rain & typhoon season) with 25% gross margin
</commit_message>
<xml_diff>
--- a/FY2027_進金生南區暨維運商業計畫報告_董總決策版.pptx
+++ b/FY2027_進金生南區暨維運商業計畫報告_董總決策版.pptx
@@ -948,10 +948,10 @@
                   <c:v>Q1</c:v>
                 </c:pt>
                 <c:pt idx="1">
-                  <c:v>Q2</c:v>
+                  <c:v>Q2 (梅雨高峰)</c:v>
                 </c:pt>
                 <c:pt idx="2">
-                  <c:v>Q3 (修繕高峰)</c:v>
+                  <c:v>Q3 (颱風高峰)</c:v>
                 </c:pt>
                 <c:pt idx="3">
                   <c:v>Q4 (修繕高峰)</c:v>
@@ -1004,10 +1004,10 @@
                   <c:v>Q1</c:v>
                 </c:pt>
                 <c:pt idx="1">
-                  <c:v>Q2</c:v>
+                  <c:v>Q2 (梅雨高峰)</c:v>
                 </c:pt>
                 <c:pt idx="2">
-                  <c:v>Q3 (修繕高峰)</c:v>
+                  <c:v>Q3 (颱風高峰)</c:v>
                 </c:pt>
                 <c:pt idx="3">
                   <c:v>Q4 (修繕高峰)</c:v>
@@ -1025,13 +1025,13 @@
                   <c:v>442</c:v>
                 </c:pt>
                 <c:pt idx="1">
-                  <c:v>739</c:v>
+                  <c:v>1452</c:v>
                 </c:pt>
                 <c:pt idx="2">
                   <c:v>2383</c:v>
                 </c:pt>
                 <c:pt idx="3">
-                  <c:v>2419</c:v>
+                  <c:v>1706</c:v>
                 </c:pt>
               </c:numCache>
             </c:numRef>
@@ -2047,7 +2047,7 @@
           <a:lstStyle/>
           <a:p>
             <a:r>
-              <a:t>【講稿 P.8 (1.5分鐘)】維運預算突破 1.01 億元、毛利 2,337 萬。其中 128 筆 JDE 長約（4,111萬）毛利率高達 35%，貢獻了超過六成的毛利，是公司最穩定的現金牛。</a:t>
+              <a:t>【講稿 P.8 (1.5分鐘)】維運預算突破 1.01 億元、毛利 2,935 萬（綜合毛利率 29.07%）。128 筆 JDE 長約（35%毛利）與 20 筆新增維運修繕商機（25%毛利）各貢獻約一半毛利，且修繕工程配合梅雨與颱風季集中於 Q2、Q3、Q4 認列。</a:t>
             </a:r>
           </a:p>
         </p:txBody>
@@ -24292,7 +24292,7 @@
                         </a:defRPr>
                       </a:pPr>
                       <a:r>
-                        <a:t>0</a:t>
+                        <a:t>4,630,500</a:t>
                       </a:r>
                     </a:p>
                   </a:txBody>
@@ -24340,7 +24340,7 @@
                         </a:defRPr>
                       </a:pPr>
                       <a:r>
-                        <a:t>6,945,750</a:t>
+                        <a:t>2,315,250</a:t>
                       </a:r>
                     </a:p>
                   </a:txBody>
@@ -25018,7 +25018,7 @@
                         </a:defRPr>
                       </a:pPr>
                       <a:r>
-                        <a:t>0</a:t>
+                        <a:t>2,500,000</a:t>
                       </a:r>
                     </a:p>
                   </a:txBody>
@@ -25066,7 +25066,7 @@
                         </a:defRPr>
                       </a:pPr>
                       <a:r>
-                        <a:t>3,750,000</a:t>
+                        <a:t>1,250,000</a:t>
                       </a:r>
                     </a:p>
                   </a:txBody>
@@ -27438,7 +27438,7 @@
                         </a:defRPr>
                       </a:pPr>
                       <a:r>
-                        <a:t>7,386,354</a:t>
+                        <a:t>14,516,854</a:t>
                       </a:r>
                     </a:p>
                   </a:txBody>
@@ -27486,7 +27486,7 @@
                         </a:defRPr>
                       </a:pPr>
                       <a:r>
-                        <a:t>24,188,355</a:t>
+                        <a:t>17,057,855</a:t>
                       </a:r>
                     </a:p>
                   </a:txBody>
@@ -38619,7 +38619,7 @@
                         </a:defRPr>
                       </a:pPr>
                       <a:r>
-                        <a:t>Q2 第二季</a:t>
+                        <a:t>Q2 第二季 (梅雨暴雨高峰)</a:t>
                       </a:r>
                     </a:p>
                   </a:txBody>
@@ -38643,7 +38643,7 @@
                         </a:defRPr>
                       </a:pPr>
                       <a:r>
-                        <a:t>17,887,955</a:t>
+                        <a:t>25,018,455</a:t>
                       </a:r>
                     </a:p>
                   </a:txBody>
@@ -38667,7 +38667,7 @@
                         </a:defRPr>
                       </a:pPr>
                       <a:r>
-                        <a:t>5,522,157</a:t>
+                        <a:t>7,304,783</a:t>
                       </a:r>
                     </a:p>
                   </a:txBody>
@@ -38691,7 +38691,7 @@
                         </a:defRPr>
                       </a:pPr>
                       <a:r>
-                        <a:t>30.87%</a:t>
+                        <a:t>29.20%</a:t>
                       </a:r>
                     </a:p>
                   </a:txBody>
@@ -38715,7 +38715,7 @@
                         </a:defRPr>
                       </a:pPr>
                       <a:r>
-                        <a:t>41.3% (外來案爬升)</a:t>
+                        <a:t>58.0% (梅雨修繕啟動)</a:t>
                       </a:r>
                     </a:p>
                   </a:txBody>
@@ -38741,7 +38741,7 @@
                         </a:defRPr>
                       </a:pPr>
                       <a:r>
-                        <a:t>Q3 第三季 (颱風修繕高峰)</a:t>
+                        <a:t>Q3 第三季 (颱風修繕最高峰)</a:t>
                       </a:r>
                     </a:p>
                   </a:txBody>
@@ -38837,7 +38837,7 @@
                         </a:defRPr>
                       </a:pPr>
                       <a:r>
-                        <a:t>70.2% (災後修繕集中)</a:t>
+                        <a:t>70.2% (颱風修繕高峰)</a:t>
                       </a:r>
                     </a:p>
                   </a:txBody>
@@ -38863,7 +38863,7 @@
                         </a:defRPr>
                       </a:pPr>
                       <a:r>
-                        <a:t>Q4 第四季 (颱風修繕高峰)</a:t>
+                        <a:t>Q4 第四季 (災後復原高峰)</a:t>
                       </a:r>
                     </a:p>
                   </a:txBody>
@@ -38887,7 +38887,7 @@
                         </a:defRPr>
                       </a:pPr>
                       <a:r>
-                        <a:t>34,122,373</a:t>
+                        <a:t>26,991,873</a:t>
                       </a:r>
                     </a:p>
                   </a:txBody>
@@ -38911,7 +38911,7 @@
                         </a:defRPr>
                       </a:pPr>
                       <a:r>
-                        <a:t>9,524,005</a:t>
+                        <a:t>7,741,379</a:t>
                       </a:r>
                     </a:p>
                   </a:txBody>
@@ -38935,7 +38935,7 @@
                         </a:defRPr>
                       </a:pPr>
                       <a:r>
-                        <a:t>27.91%</a:t>
+                        <a:t>28.68%</a:t>
                       </a:r>
                     </a:p>
                   </a:txBody>
@@ -38959,7 +38959,7 @@
                         </a:defRPr>
                       </a:pPr>
                       <a:r>
-                        <a:t>70.9% (災後修繕集中)</a:t>
+                        <a:t>63.2% (災後修繕收尾)</a:t>
                       </a:r>
                     </a:p>
                   </a:txBody>
@@ -40002,7 +40002,7 @@
               </a:defRPr>
             </a:pPr>
             <a:r>
-              <a:t>維運商機 5,982 萬中「預估佔位 3,750 萬（62.7%）」將綁定既有 128 案技改配額落地，並優化毛利率至 22%+</a:t>
+              <a:t>維運商機 5,982 萬（毛利率 25% / 毛利 1,496 萬）配合梅雨與颱風季於 Q2~Q4 進入高峰，並以既有 128 案配額落地</a:t>
             </a:r>
           </a:p>
           <a:p>
@@ -40015,7 +40015,7 @@
               </a:defRPr>
             </a:pPr>
             <a:r>
-              <a:t>鎖定旭忠水上型修繕 (1,389萬) 與 BP/國泰/永鑫外來轉單案；同步清查 JDE 8 筆零元合約找回高毛利續約金流</a:t>
+              <a:t>鎖定旭忠水上型修繕 (1,389萬，5~10月執行) 與 BP/國泰/永鑫外來轉單案；同步清查 JDE 8 筆零元合約找回高毛利續約金流</a:t>
             </a:r>
           </a:p>
         </p:txBody>

</xml_diff>